<commit_message>
docs(submission): record the demo video and feature a live MiMo ranking (ISS-3642)
Co-Authored-By: Claude Opus 5.5 <noreply@anthropic.com>
</commit_message>
<xml_diff>
--- a/docs/submission/ResponseCompass-deck.pptx
+++ b/docs/submission/ResponseCompass-deck.pptx
@@ -1001,7 +1001,7 @@
           <a:lstStyle/>
           <a:p>
             <a:r>
-              <a:t>A disagreement marker in the event feed means Compass chose differently from either baseline. Open the recommendation record to see which baseline and to read the rationale.</a:t>
+              <a:t>This record was captured live on AMD Token Factory with MiMo-V2.6-Flash on 2026-10-17 (simulated time 6 October). Both baselines picked someone else: nearest chose Optr375, the naive score chose Tech363. One good outcome is not proof of better performance; the disagreement is recorded so it can be reviewed. In that capture, 7 of 11 live rankings returned valid output; the rest fell back deterministically.</a:t>
             </a:r>
           </a:p>
         </p:txBody>
@@ -7920,7 +7920,7 @@
                 </a:solidFill>
                 <a:latin typeface="Inter"/>
               </a:rPr>
-              <a:t>Live demo highlights</a:t>
+              <a:t>A real MiMo ranking, end to end</a:t>
             </a:r>
           </a:p>
         </p:txBody>
@@ -7933,8 +7933,8 @@
         </p:nvSpPr>
         <p:spPr>
           <a:xfrm>
-            <a:off x="548640" y="1463040"/>
-            <a:ext cx="5120640" cy="4754880"/>
+            <a:off x="548640" y="1051560"/>
+            <a:ext cx="11064240" cy="457200"/>
           </a:xfrm>
           <a:prstGeom prst="rect">
             <a:avLst/>
@@ -7942,6 +7942,41 @@
           <a:noFill/>
         </p:spPr>
         <p:txBody>
+          <a:bodyPr wrap="square" lIns="0" rIns="0" tIns="0" bIns="0">
+            <a:spAutoFit/>
+          </a:bodyPr>
+          <a:lstStyle/>
+          <a:p>
+            <a:pPr algn="l"/>
+            <a:r>
+              <a:rPr sz="1600" b="0">
+                <a:solidFill>
+                  <a:srgbClr val="5B6474"/>
+                </a:solidFill>
+                <a:latin typeface="Inter"/>
+              </a:rPr>
+              <a:t>ISS-3642, captured live on AMD Token Factory (MiMo-V2.6-Flash)</a:t>
+            </a:r>
+          </a:p>
+        </p:txBody>
+      </p:sp>
+      <p:sp>
+        <p:nvSpPr>
+          <p:cNvPr id="4" name="TextBox 3"/>
+          <p:cNvSpPr txBox="1"/>
+          <p:nvPr/>
+        </p:nvSpPr>
+        <p:spPr>
+          <a:xfrm>
+            <a:off x="548640" y="1737360"/>
+            <a:ext cx="4206240" cy="4572000"/>
+          </a:xfrm>
+          <a:prstGeom prst="rect">
+            <a:avLst/>
+          </a:prstGeom>
+          <a:noFill/>
+        </p:spPr>
+        <p:txBody>
           <a:bodyPr wrap="square">
             <a:spAutoFit/>
           </a:bodyPr>
@@ -7949,11 +7984,11 @@
           <a:p>
             <a:pPr>
               <a:spcAft>
-                <a:spcPts val="1440"/>
+                <a:spcPts val="1360"/>
               </a:spcAft>
             </a:pPr>
             <a:r>
-              <a:rPr sz="1800" b="1">
+              <a:rPr sz="1700" b="1">
                 <a:solidFill>
                   <a:srgbClr val="0F8B8D"/>
                 </a:solidFill>
@@ -7962,23 +7997,41 @@
               <a:t>▸  </a:t>
             </a:r>
             <a:r>
-              <a:rPr sz="1800" b="0">
+              <a:rPr sz="1700" b="0">
                 <a:solidFill>
                   <a:srgbClr val="1F2937"/>
                 </a:solidFill>
                 <a:latin typeface="Inter"/>
               </a:rPr>
-              <a:t>Live Floor: three floors, 2D map and 2.5D overview, issues and responders in real time.</a:t>
+              <a:t>Nearest responder: </a:t>
+            </a:r>
+            <a:r>
+              <a:rPr sz="1700" b="1">
+                <a:solidFill>
+                  <a:srgbClr val="16213E"/>
+                </a:solidFill>
+                <a:latin typeface="Inter"/>
+              </a:rPr>
+              <a:t>Optr375</a:t>
+            </a:r>
+            <a:r>
+              <a:rPr sz="1700" b="0">
+                <a:solidFill>
+                  <a:srgbClr val="1F2937"/>
+                </a:solidFill>
+                <a:latin typeface="Inter"/>
+              </a:rPr>
+              <a:t>, 0.8 min away, thin history on this fault.</a:t>
             </a:r>
           </a:p>
           <a:p>
             <a:pPr>
               <a:spcAft>
-                <a:spcPts val="1440"/>
+                <a:spcPts val="1360"/>
               </a:spcAft>
             </a:pPr>
             <a:r>
-              <a:rPr sz="1800" b="1">
+              <a:rPr sz="1700" b="1">
                 <a:solidFill>
                   <a:srgbClr val="0F8B8D"/>
                 </a:solidFill>
@@ -7987,23 +8040,41 @@
               <a:t>▸  </a:t>
             </a:r>
             <a:r>
-              <a:rPr sz="1800" b="0">
+              <a:rPr sz="1700" b="0">
                 <a:solidFill>
                   <a:srgbClr val="1F2937"/>
                 </a:solidFill>
                 <a:latin typeface="Inter"/>
               </a:rPr>
-              <a:t>Compass ranking with rationale; offer, accept, reject; help for complex work.</a:t>
+              <a:t>Compass ranked </a:t>
+            </a:r>
+            <a:r>
+              <a:rPr sz="1700" b="1">
+                <a:solidFill>
+                  <a:srgbClr val="16213E"/>
+                </a:solidFill>
+                <a:latin typeface="Inter"/>
+              </a:rPr>
+              <a:t>Engr370</a:t>
+            </a:r>
+            <a:r>
+              <a:rPr sz="1700" b="0">
+                <a:solidFill>
+                  <a:srgbClr val="1F2937"/>
+                </a:solidFill>
+                <a:latin typeface="Inter"/>
+              </a:rPr>
+              <a:t> first: deepest evidence, 92% success, 2 min away.</a:t>
             </a:r>
           </a:p>
           <a:p>
             <a:pPr>
               <a:spcAft>
-                <a:spcPts val="1440"/>
+                <a:spcPts val="1360"/>
               </a:spcAft>
             </a:pPr>
             <a:r>
-              <a:rPr sz="1800" b="1">
+              <a:rPr sz="1700" b="1">
                 <a:solidFill>
                   <a:srgbClr val="0F8B8D"/>
                 </a:solidFill>
@@ -8012,23 +8083,41 @@
               <a:t>▸  </a:t>
             </a:r>
             <a:r>
-              <a:rPr sz="1800" b="0">
+              <a:rPr sz="1700" b="0">
                 <a:solidFill>
                   <a:srgbClr val="1F2937"/>
                 </a:solidFill>
                 <a:latin typeface="Inter"/>
               </a:rPr>
-              <a:t>Override and force-resolve; one-click audit trail per issue.</a:t>
+              <a:t>Offer accepted; resolved first time in </a:t>
+            </a:r>
+            <a:r>
+              <a:rPr sz="1700" b="1">
+                <a:solidFill>
+                  <a:srgbClr val="16213E"/>
+                </a:solidFill>
+                <a:latin typeface="Inter"/>
+              </a:rPr>
+              <a:t>11.2 min</a:t>
+            </a:r>
+            <a:r>
+              <a:rPr sz="1700" b="0">
+                <a:solidFill>
+                  <a:srgbClr val="1F2937"/>
+                </a:solidFill>
+                <a:latin typeface="Inter"/>
+              </a:rPr>
+              <a:t>.</a:t>
             </a:r>
           </a:p>
           <a:p>
             <a:pPr>
               <a:spcAft>
-                <a:spcPts val="1440"/>
+                <a:spcPts val="1360"/>
               </a:spcAft>
             </a:pPr>
             <a:r>
-              <a:rPr sz="1800" b="1">
+              <a:rPr sz="1700" b="1">
                 <a:solidFill>
                   <a:srgbClr val="0F8B8D"/>
                 </a:solidFill>
@@ -8037,20 +8126,20 @@
               <a:t>▸  </a:t>
             </a:r>
             <a:r>
-              <a:rPr sz="1800" b="0">
+              <a:rPr sz="1700" b="0">
                 <a:solidFill>
                   <a:srgbClr val="1F2937"/>
                 </a:solidFill>
                 <a:latin typeface="Inter"/>
               </a:rPr>
-              <a:t>Two independent control rooms (e8-aura-p1, e8-aura-p2).</a:t>
+              <a:t>Every step, and the action taken, is in the issue's audit trail.</a:t>
             </a:r>
           </a:p>
         </p:txBody>
       </p:sp>
       <p:pic>
         <p:nvPicPr>
-          <p:cNvPr id="4" name="Picture 3" descr="live-floor.png"/>
+          <p:cNvPr id="5" name="Picture 4" descr="compass-record.png"/>
           <p:cNvPicPr>
             <a:picLocks noChangeAspect="1"/>
           </p:cNvPicPr>
@@ -8064,8 +8153,8 @@
         </p:blipFill>
         <p:spPr>
           <a:xfrm>
-            <a:off x="5943600" y="1463040"/>
-            <a:ext cx="5806440" cy="3266122"/>
+            <a:off x="4983480" y="1691640"/>
+            <a:ext cx="6812280" cy="3214853"/>
           </a:xfrm>
           <a:prstGeom prst="rect">
             <a:avLst/>
@@ -8079,7 +8168,7 @@
       </p:pic>
       <p:sp>
         <p:nvSpPr>
-          <p:cNvPr id="5" name="TextBox 4"/>
+          <p:cNvPr id="6" name="TextBox 5"/>
           <p:cNvSpPr txBox="1"/>
           <p:nvPr/>
         </p:nvSpPr>

</xml_diff>

<commit_message>
docs(submission): final 2:51 video and deck in the refined UI
Recorded against a paused copy of the live AMD capture: wall screens, ISS-3618
responder and fix rankings, staffing-7 approved by central command, Offline,
analytics and the Issue Pareto. Deck screenshots retaken; slides 9 and 12
re-laid out; test counts 319 / 71.

Co-Authored-By: Claude Opus 5.5 <noreply@anthropic.com>
</commit_message>
<xml_diff>
--- a/docs/submission/ResponseCompass-deck.pptx
+++ b/docs/submission/ResponseCompass-deck.pptx
@@ -5322,7 +5322,7 @@
         <p:spPr>
           <a:xfrm>
             <a:off x="5669280" y="1463040"/>
-            <a:ext cx="6080760" cy="3527001"/>
+            <a:ext cx="6080760" cy="4279053"/>
           </a:xfrm>
           <a:prstGeom prst="rect">
             <a:avLst/>
@@ -5438,8 +5438,8 @@
         </p:nvSpPr>
         <p:spPr>
           <a:xfrm>
-            <a:off x="548640" y="1463040"/>
-            <a:ext cx="6766560" cy="4754880"/>
+            <a:off x="548640" y="1371600"/>
+            <a:ext cx="11064240" cy="3291840"/>
           </a:xfrm>
           <a:prstGeom prst="rect">
             <a:avLst/>
@@ -5648,8 +5648,8 @@
         </p:blipFill>
         <p:spPr>
           <a:xfrm>
-            <a:off x="7818120" y="1371600"/>
-            <a:ext cx="4248336" cy="4937760"/>
+            <a:off x="1463040" y="4617720"/>
+            <a:ext cx="7863840" cy="2030535"/>
           </a:xfrm>
           <a:prstGeom prst="rect">
             <a:avLst/>
@@ -5825,7 +5825,7 @@
                 </a:solidFill>
                 <a:latin typeface="Inter"/>
               </a:rPr>
-              <a:t>317</a:t>
+              <a:t>319</a:t>
             </a:r>
             <a:r>
               <a:rPr sz="2100" b="0">
@@ -5843,7 +5843,7 @@
                 </a:solidFill>
                 <a:latin typeface="Inter"/>
               </a:rPr>
-              <a:t>67</a:t>
+              <a:t>71</a:t>
             </a:r>
             <a:r>
               <a:rPr sz="2100" b="0">
@@ -11811,7 +11811,7 @@
         <p:spPr>
           <a:xfrm>
             <a:off x="4983480" y="1600200"/>
-            <a:ext cx="6812280" cy="2986049"/>
+            <a:ext cx="6812280" cy="3093910"/>
           </a:xfrm>
           <a:prstGeom prst="rect">
             <a:avLst/>
@@ -12130,7 +12130,7 @@
         <p:spPr>
           <a:xfrm>
             <a:off x="4846320" y="1600200"/>
-            <a:ext cx="6858000" cy="4252187"/>
+            <a:ext cx="6858000" cy="4314635"/>
           </a:xfrm>
           <a:prstGeom prst="rect">
             <a:avLst/>

</xml_diff>